<commit_message>
docs: refine project status presentation visuals
Co-authored-by: 程序员鱼皮 <592789970@qq.com>
</commit_message>
<xml_diff>
--- a/docs/reports/project-status-2026-07-22.pptx
+++ b/docs/reports/project-status-2026-07-22.pptx
@@ -2334,7 +2334,7 @@
         <p:spPr>
           <a:xfrm>
             <a:off x="685800" y="1874520"/>
-            <a:ext cx="7680960" cy="1115568"/>
+            <a:ext cx="8823960" cy="713232"/>
           </a:xfrm>
           <a:prstGeom prst="rect">
             <a:avLst/>
@@ -2352,7 +2352,7 @@
               <a:buNone/>
             </a:pPr>
             <a:r>
-              <a:rPr lang="en-US" sz="3100" b="1" dirty="0">
+              <a:rPr lang="en-US" sz="3600" b="1" dirty="0">
                 <a:solidFill>
                   <a:srgbClr val="67E8D4"/>
                 </a:solidFill>
@@ -2360,26 +2360,9 @@
                 <a:ea typeface="Georgia" pitchFamily="34" charset="-122"/>
                 <a:cs typeface="Georgia" pitchFamily="34" charset="-120"/>
               </a:rPr>
-              <a:t>功能覆盖面强，当前瓶颈是交付可信度，</a:t>
-            </a:r>
-            <a:endParaRPr lang="en-US" sz="3100" dirty="0"/>
-          </a:p>
-          <a:p>
-            <a:pPr algn="l" indent="0" marL="0">
-              <a:buNone/>
-            </a:pPr>
-            <a:r>
-              <a:rPr lang="en-US" sz="3100" b="1" dirty="0">
-                <a:solidFill>
-                  <a:srgbClr val="67E8D4"/>
-                </a:solidFill>
-                <a:latin typeface="Georgia" pitchFamily="34" charset="0"/>
-                <a:ea typeface="Georgia" pitchFamily="34" charset="-122"/>
-                <a:cs typeface="Georgia" pitchFamily="34" charset="-120"/>
-              </a:rPr>
-              <a:t>而不是功能数量。</a:t>
-            </a:r>
-            <a:endParaRPr lang="en-US" sz="3100" dirty="0"/>
+              <a:t>核心瓶颈在交付可信度，而非功能覆盖</a:t>
+            </a:r>
+            <a:endParaRPr lang="en-US" sz="3600" dirty="0"/>
           </a:p>
         </p:txBody>
       </p:sp>
@@ -8611,7 +8594,7 @@
                 <a:ea typeface="Calibri" pitchFamily="34" charset="-122"/>
                 <a:cs typeface="Calibri" pitchFamily="34" charset="-120"/>
               </a:rPr>
-              <a:t>08·13</a:t>
+              <a:t>08-13</a:t>
             </a:r>
             <a:endParaRPr lang="en-US" sz="1150" dirty="0"/>
           </a:p>
@@ -8788,7 +8771,7 @@
                 <a:ea typeface="Calibri" pitchFamily="34" charset="-122"/>
                 <a:cs typeface="Calibri" pitchFamily="34" charset="-120"/>
               </a:rPr>
-              <a:t>08·14</a:t>
+              <a:t>08-14</a:t>
             </a:r>
             <a:endParaRPr lang="en-US" sz="1150" dirty="0"/>
           </a:p>
@@ -8965,7 +8948,7 @@
                 <a:ea typeface="Calibri" pitchFamily="34" charset="-122"/>
                 <a:cs typeface="Calibri" pitchFamily="34" charset="-120"/>
               </a:rPr>
-              <a:t>08·26</a:t>
+              <a:t>08-26</a:t>
             </a:r>
             <a:endParaRPr lang="en-US" sz="1150" dirty="0"/>
           </a:p>
@@ -10342,7 +10325,7 @@
                 <a:ea typeface="Calibri" pitchFamily="34" charset="-122"/>
                 <a:cs typeface="Calibri" pitchFamily="34" charset="-120"/>
               </a:rPr>
-              <a:t>Actuator 暴露 health / info / prometheus。</a:t>
+              <a:t>Actuator 端点：health、info、prometheus。</a:t>
             </a:r>
             <a:endParaRPr lang="en-US" sz="1150" dirty="0"/>
           </a:p>
@@ -12930,11 +12913,11 @@
         <p:spPr>
           <a:xfrm>
             <a:off x="585216" y="1993392"/>
-            <a:ext cx="5184648" cy="1737360"/>
+            <a:ext cx="5184648" cy="1847088"/>
           </a:xfrm>
           <a:prstGeom prst="roundRect">
             <a:avLst>
-              <a:gd name="adj" fmla="val 4211"/>
+              <a:gd name="adj" fmla="val 3960"/>
             </a:avLst>
           </a:prstGeom>
           <a:solidFill>
@@ -13109,11 +13092,11 @@
         <p:spPr>
           <a:xfrm>
             <a:off x="6007608" y="1993392"/>
-            <a:ext cx="5184648" cy="1737360"/>
+            <a:ext cx="5184648" cy="1847088"/>
           </a:xfrm>
           <a:prstGeom prst="roundRect">
             <a:avLst>
-              <a:gd name="adj" fmla="val 4211"/>
+              <a:gd name="adj" fmla="val 3960"/>
             </a:avLst>
           </a:prstGeom>
           <a:solidFill>
@@ -13287,20 +13270,20 @@
         </p:nvSpPr>
         <p:spPr>
           <a:xfrm>
-            <a:off x="585216" y="4078224"/>
-            <a:ext cx="5184648" cy="1737360"/>
+            <a:off x="585216" y="3959352"/>
+            <a:ext cx="5184648" cy="1847088"/>
           </a:xfrm>
           <a:prstGeom prst="roundRect">
             <a:avLst>
-              <a:gd name="adj" fmla="val 4211"/>
+              <a:gd name="adj" fmla="val 3960"/>
             </a:avLst>
           </a:prstGeom>
           <a:solidFill>
-            <a:srgbClr val="E6FFFA"/>
+            <a:srgbClr val="FFF5D6"/>
           </a:solidFill>
           <a:ln w="15240">
             <a:solidFill>
-              <a:srgbClr val="028090"/>
+              <a:srgbClr val="F59E0B"/>
             </a:solidFill>
             <a:prstDash val="solid"/>
           </a:ln>
@@ -13314,7 +13297,7 @@
         </p:nvSpPr>
         <p:spPr>
           <a:xfrm>
-            <a:off x="804672" y="4288536"/>
+            <a:off x="804672" y="4169664"/>
             <a:ext cx="658368" cy="457200"/>
           </a:xfrm>
           <a:prstGeom prst="roundRect">
@@ -13323,11 +13306,11 @@
             </a:avLst>
           </a:prstGeom>
           <a:solidFill>
-            <a:srgbClr val="028090"/>
+            <a:srgbClr val="F59E0B"/>
           </a:solidFill>
           <a:ln w="12700">
             <a:solidFill>
-              <a:srgbClr val="028090">
+              <a:srgbClr val="F59E0B">
                 <a:alpha val="0"/>
               </a:srgbClr>
             </a:solidFill>
@@ -13343,7 +13326,7 @@
         </p:nvSpPr>
         <p:spPr>
           <a:xfrm>
-            <a:off x="804672" y="4288536"/>
+            <a:off x="804672" y="4169664"/>
             <a:ext cx="658368" cy="457200"/>
           </a:xfrm>
           <a:prstGeom prst="rect">
@@ -13384,7 +13367,7 @@
         </p:nvSpPr>
         <p:spPr>
           <a:xfrm>
-            <a:off x="1609344" y="4279392"/>
+            <a:off x="1609344" y="4160520"/>
             <a:ext cx="3886200" cy="457200"/>
           </a:xfrm>
           <a:prstGeom prst="rect">
@@ -13425,7 +13408,7 @@
         </p:nvSpPr>
         <p:spPr>
           <a:xfrm>
-            <a:off x="813816" y="4919472"/>
+            <a:off x="813816" y="4800600"/>
             <a:ext cx="4727448" cy="640080"/>
           </a:xfrm>
           <a:prstGeom prst="rect">
@@ -13466,20 +13449,20 @@
         </p:nvSpPr>
         <p:spPr>
           <a:xfrm>
-            <a:off x="6007608" y="4078224"/>
-            <a:ext cx="5184648" cy="1737360"/>
+            <a:off x="6007608" y="3959352"/>
+            <a:ext cx="5184648" cy="1847088"/>
           </a:xfrm>
           <a:prstGeom prst="roundRect">
             <a:avLst>
-              <a:gd name="adj" fmla="val 4211"/>
+              <a:gd name="adj" fmla="val 3960"/>
             </a:avLst>
           </a:prstGeom>
           <a:solidFill>
-            <a:srgbClr val="E0F2FE"/>
+            <a:srgbClr val="FFF5D6"/>
           </a:solidFill>
           <a:ln w="15240">
             <a:solidFill>
-              <a:srgbClr val="064E5E"/>
+              <a:srgbClr val="F59E0B"/>
             </a:solidFill>
             <a:prstDash val="solid"/>
           </a:ln>
@@ -13493,7 +13476,7 @@
         </p:nvSpPr>
         <p:spPr>
           <a:xfrm>
-            <a:off x="6227064" y="4288536"/>
+            <a:off x="6227064" y="4169664"/>
             <a:ext cx="658368" cy="457200"/>
           </a:xfrm>
           <a:prstGeom prst="roundRect">
@@ -13502,11 +13485,11 @@
             </a:avLst>
           </a:prstGeom>
           <a:solidFill>
-            <a:srgbClr val="064E5E"/>
+            <a:srgbClr val="F59E0B"/>
           </a:solidFill>
           <a:ln w="12700">
             <a:solidFill>
-              <a:srgbClr val="064E5E">
+              <a:srgbClr val="F59E0B">
                 <a:alpha val="0"/>
               </a:srgbClr>
             </a:solidFill>
@@ -13522,7 +13505,7 @@
         </p:nvSpPr>
         <p:spPr>
           <a:xfrm>
-            <a:off x="6227064" y="4288536"/>
+            <a:off x="6227064" y="4169664"/>
             <a:ext cx="658368" cy="457200"/>
           </a:xfrm>
           <a:prstGeom prst="rect">
@@ -13563,7 +13546,7 @@
         </p:nvSpPr>
         <p:spPr>
           <a:xfrm>
-            <a:off x="7031736" y="4279392"/>
+            <a:off x="7031736" y="4160520"/>
             <a:ext cx="3886200" cy="457200"/>
           </a:xfrm>
           <a:prstGeom prst="rect">
@@ -13604,7 +13587,7 @@
         </p:nvSpPr>
         <p:spPr>
           <a:xfrm>
-            <a:off x="6236208" y="4919472"/>
+            <a:off x="6236208" y="4800600"/>
             <a:ext cx="4727448" cy="640080"/>
           </a:xfrm>
           <a:prstGeom prst="rect">
@@ -14073,15 +14056,15 @@
           </a:xfrm>
           <a:prstGeom prst="roundRect">
             <a:avLst>
-              <a:gd name="adj" fmla="val 23529"/>
+              <a:gd name="adj" fmla="val 17647"/>
             </a:avLst>
           </a:prstGeom>
           <a:solidFill>
-            <a:srgbClr val="FDE8E8"/>
+            <a:srgbClr val="D65A5A"/>
           </a:solidFill>
           <a:ln w="12700">
             <a:solidFill>
-              <a:srgbClr val="FDE8E8">
+              <a:srgbClr val="D65A5A">
                 <a:alpha val="0"/>
               </a:srgbClr>
             </a:solidFill>
@@ -14097,28 +14080,28 @@
         </p:nvSpPr>
         <p:spPr>
           <a:xfrm>
-            <a:off x="1773936" y="2148840"/>
-            <a:ext cx="347472" cy="283464"/>
-          </a:xfrm>
-          <a:prstGeom prst="rect">
-            <a:avLst/>
-          </a:prstGeom>
-          <a:noFill/>
-          <a:ln/>
-        </p:spPr>
-        <p:txBody>
-          <a:bodyPr wrap="square" lIns="0" tIns="0" rIns="0" bIns="0" rtlCol="0" anchor="ctr">
-            <a:normAutofit/>
-          </a:bodyPr>
-          <a:lstStyle/>
-          <a:p>
-            <a:pPr algn="l" indent="0" marL="0">
-              <a:buNone/>
-            </a:pPr>
-            <a:r>
-              <a:rPr lang="en-US" sz="1150" b="1" spc="40" kern="0" dirty="0">
-                <a:solidFill>
-                  <a:srgbClr val="D65A5A"/>
+            <a:off x="1664208" y="2148840"/>
+            <a:ext cx="566928" cy="283464"/>
+          </a:xfrm>
+          <a:prstGeom prst="rect">
+            <a:avLst/>
+          </a:prstGeom>
+          <a:noFill/>
+          <a:ln/>
+        </p:spPr>
+        <p:txBody>
+          <a:bodyPr wrap="square" lIns="0" tIns="0" rIns="0" bIns="0" rtlCol="0" anchor="ctr">
+            <a:normAutofit/>
+          </a:bodyPr>
+          <a:lstStyle/>
+          <a:p>
+            <a:pPr algn="ctr" indent="0" marL="0">
+              <a:buNone/>
+            </a:pPr>
+            <a:r>
+              <a:rPr lang="en-US" sz="1150" b="1" dirty="0">
+                <a:solidFill>
+                  <a:srgbClr val="FFFFFF"/>
                 </a:solidFill>
                 <a:latin typeface="Calibri" pitchFamily="34" charset="0"/>
                 <a:ea typeface="Calibri" pitchFamily="34" charset="-122"/>
@@ -14291,15 +14274,15 @@
           </a:xfrm>
           <a:prstGeom prst="roundRect">
             <a:avLst>
-              <a:gd name="adj" fmla="val 23529"/>
+              <a:gd name="adj" fmla="val 17647"/>
             </a:avLst>
           </a:prstGeom>
           <a:solidFill>
-            <a:srgbClr val="FDE8E8"/>
+            <a:srgbClr val="D65A5A"/>
           </a:solidFill>
           <a:ln w="12700">
             <a:solidFill>
-              <a:srgbClr val="FDE8E8">
+              <a:srgbClr val="D65A5A">
                 <a:alpha val="0"/>
               </a:srgbClr>
             </a:solidFill>
@@ -14315,28 +14298,28 @@
         </p:nvSpPr>
         <p:spPr>
           <a:xfrm>
-            <a:off x="1773936" y="2971800"/>
-            <a:ext cx="347472" cy="283464"/>
-          </a:xfrm>
-          <a:prstGeom prst="rect">
-            <a:avLst/>
-          </a:prstGeom>
-          <a:noFill/>
-          <a:ln/>
-        </p:spPr>
-        <p:txBody>
-          <a:bodyPr wrap="square" lIns="0" tIns="0" rIns="0" bIns="0" rtlCol="0" anchor="ctr">
-            <a:normAutofit/>
-          </a:bodyPr>
-          <a:lstStyle/>
-          <a:p>
-            <a:pPr algn="l" indent="0" marL="0">
-              <a:buNone/>
-            </a:pPr>
-            <a:r>
-              <a:rPr lang="en-US" sz="1150" b="1" spc="40" kern="0" dirty="0">
-                <a:solidFill>
-                  <a:srgbClr val="D65A5A"/>
+            <a:off x="1664208" y="2971800"/>
+            <a:ext cx="566928" cy="283464"/>
+          </a:xfrm>
+          <a:prstGeom prst="rect">
+            <a:avLst/>
+          </a:prstGeom>
+          <a:noFill/>
+          <a:ln/>
+        </p:spPr>
+        <p:txBody>
+          <a:bodyPr wrap="square" lIns="0" tIns="0" rIns="0" bIns="0" rtlCol="0" anchor="ctr">
+            <a:normAutofit/>
+          </a:bodyPr>
+          <a:lstStyle/>
+          <a:p>
+            <a:pPr algn="ctr" indent="0" marL="0">
+              <a:buNone/>
+            </a:pPr>
+            <a:r>
+              <a:rPr lang="en-US" sz="1150" b="1" dirty="0">
+                <a:solidFill>
+                  <a:srgbClr val="FFFFFF"/>
                 </a:solidFill>
                 <a:latin typeface="Calibri" pitchFamily="34" charset="0"/>
                 <a:ea typeface="Calibri" pitchFamily="34" charset="-122"/>
@@ -14509,15 +14492,15 @@
           </a:xfrm>
           <a:prstGeom prst="roundRect">
             <a:avLst>
-              <a:gd name="adj" fmla="val 23529"/>
+              <a:gd name="adj" fmla="val 17647"/>
             </a:avLst>
           </a:prstGeom>
           <a:solidFill>
-            <a:srgbClr val="FFF5D6"/>
+            <a:srgbClr val="F59E0B"/>
           </a:solidFill>
           <a:ln w="12700">
             <a:solidFill>
-              <a:srgbClr val="FFF5D6">
+              <a:srgbClr val="F59E0B">
                 <a:alpha val="0"/>
               </a:srgbClr>
             </a:solidFill>
@@ -14533,28 +14516,28 @@
         </p:nvSpPr>
         <p:spPr>
           <a:xfrm>
-            <a:off x="1773936" y="3794760"/>
-            <a:ext cx="347472" cy="283464"/>
-          </a:xfrm>
-          <a:prstGeom prst="rect">
-            <a:avLst/>
-          </a:prstGeom>
-          <a:noFill/>
-          <a:ln/>
-        </p:spPr>
-        <p:txBody>
-          <a:bodyPr wrap="square" lIns="0" tIns="0" rIns="0" bIns="0" rtlCol="0" anchor="ctr">
-            <a:normAutofit/>
-          </a:bodyPr>
-          <a:lstStyle/>
-          <a:p>
-            <a:pPr algn="l" indent="0" marL="0">
-              <a:buNone/>
-            </a:pPr>
-            <a:r>
-              <a:rPr lang="en-US" sz="1150" b="1" spc="40" kern="0" dirty="0">
-                <a:solidFill>
-                  <a:srgbClr val="F59E0B"/>
+            <a:off x="1664208" y="3794760"/>
+            <a:ext cx="566928" cy="283464"/>
+          </a:xfrm>
+          <a:prstGeom prst="rect">
+            <a:avLst/>
+          </a:prstGeom>
+          <a:noFill/>
+          <a:ln/>
+        </p:spPr>
+        <p:txBody>
+          <a:bodyPr wrap="square" lIns="0" tIns="0" rIns="0" bIns="0" rtlCol="0" anchor="ctr">
+            <a:normAutofit/>
+          </a:bodyPr>
+          <a:lstStyle/>
+          <a:p>
+            <a:pPr algn="ctr" indent="0" marL="0">
+              <a:buNone/>
+            </a:pPr>
+            <a:r>
+              <a:rPr lang="en-US" sz="1150" b="1" dirty="0">
+                <a:solidFill>
+                  <a:srgbClr val="5C3900"/>
                 </a:solidFill>
                 <a:latin typeface="Calibri" pitchFamily="34" charset="0"/>
                 <a:ea typeface="Calibri" pitchFamily="34" charset="-122"/>
@@ -14727,15 +14710,15 @@
           </a:xfrm>
           <a:prstGeom prst="roundRect">
             <a:avLst>
-              <a:gd name="adj" fmla="val 23529"/>
+              <a:gd name="adj" fmla="val 17647"/>
             </a:avLst>
           </a:prstGeom>
           <a:solidFill>
-            <a:srgbClr val="FFF5D6"/>
+            <a:srgbClr val="F59E0B"/>
           </a:solidFill>
           <a:ln w="12700">
             <a:solidFill>
-              <a:srgbClr val="FFF5D6">
+              <a:srgbClr val="F59E0B">
                 <a:alpha val="0"/>
               </a:srgbClr>
             </a:solidFill>
@@ -14751,28 +14734,28 @@
         </p:nvSpPr>
         <p:spPr>
           <a:xfrm>
-            <a:off x="1773936" y="4617720"/>
-            <a:ext cx="347472" cy="283464"/>
-          </a:xfrm>
-          <a:prstGeom prst="rect">
-            <a:avLst/>
-          </a:prstGeom>
-          <a:noFill/>
-          <a:ln/>
-        </p:spPr>
-        <p:txBody>
-          <a:bodyPr wrap="square" lIns="0" tIns="0" rIns="0" bIns="0" rtlCol="0" anchor="ctr">
-            <a:normAutofit/>
-          </a:bodyPr>
-          <a:lstStyle/>
-          <a:p>
-            <a:pPr algn="l" indent="0" marL="0">
-              <a:buNone/>
-            </a:pPr>
-            <a:r>
-              <a:rPr lang="en-US" sz="1150" b="1" spc="40" kern="0" dirty="0">
-                <a:solidFill>
-                  <a:srgbClr val="F59E0B"/>
+            <a:off x="1664208" y="4617720"/>
+            <a:ext cx="566928" cy="283464"/>
+          </a:xfrm>
+          <a:prstGeom prst="rect">
+            <a:avLst/>
+          </a:prstGeom>
+          <a:noFill/>
+          <a:ln/>
+        </p:spPr>
+        <p:txBody>
+          <a:bodyPr wrap="square" lIns="0" tIns="0" rIns="0" bIns="0" rtlCol="0" anchor="ctr">
+            <a:normAutofit/>
+          </a:bodyPr>
+          <a:lstStyle/>
+          <a:p>
+            <a:pPr algn="ctr" indent="0" marL="0">
+              <a:buNone/>
+            </a:pPr>
+            <a:r>
+              <a:rPr lang="en-US" sz="1150" b="1" dirty="0">
+                <a:solidFill>
+                  <a:srgbClr val="5C3900"/>
                 </a:solidFill>
                 <a:latin typeface="Calibri" pitchFamily="34" charset="0"/>
                 <a:ea typeface="Calibri" pitchFamily="34" charset="-122"/>
@@ -14945,15 +14928,15 @@
           </a:xfrm>
           <a:prstGeom prst="roundRect">
             <a:avLst>
-              <a:gd name="adj" fmla="val 23529"/>
+              <a:gd name="adj" fmla="val 17647"/>
             </a:avLst>
           </a:prstGeom>
           <a:solidFill>
-            <a:srgbClr val="E6FFFA"/>
+            <a:srgbClr val="028090"/>
           </a:solidFill>
           <a:ln w="12700">
             <a:solidFill>
-              <a:srgbClr val="E6FFFA">
+              <a:srgbClr val="028090">
                 <a:alpha val="0"/>
               </a:srgbClr>
             </a:solidFill>
@@ -14969,28 +14952,28 @@
         </p:nvSpPr>
         <p:spPr>
           <a:xfrm>
-            <a:off x="1773936" y="5440680"/>
-            <a:ext cx="347472" cy="283464"/>
-          </a:xfrm>
-          <a:prstGeom prst="rect">
-            <a:avLst/>
-          </a:prstGeom>
-          <a:noFill/>
-          <a:ln/>
-        </p:spPr>
-        <p:txBody>
-          <a:bodyPr wrap="square" lIns="0" tIns="0" rIns="0" bIns="0" rtlCol="0" anchor="ctr">
-            <a:normAutofit/>
-          </a:bodyPr>
-          <a:lstStyle/>
-          <a:p>
-            <a:pPr algn="l" indent="0" marL="0">
-              <a:buNone/>
-            </a:pPr>
-            <a:r>
-              <a:rPr lang="en-US" sz="1150" b="1" spc="40" kern="0" dirty="0">
-                <a:solidFill>
-                  <a:srgbClr val="028090"/>
+            <a:off x="1664208" y="5440680"/>
+            <a:ext cx="566928" cy="283464"/>
+          </a:xfrm>
+          <a:prstGeom prst="rect">
+            <a:avLst/>
+          </a:prstGeom>
+          <a:noFill/>
+          <a:ln/>
+        </p:spPr>
+        <p:txBody>
+          <a:bodyPr wrap="square" lIns="0" tIns="0" rIns="0" bIns="0" rtlCol="0" anchor="ctr">
+            <a:normAutofit/>
+          </a:bodyPr>
+          <a:lstStyle/>
+          <a:p>
+            <a:pPr algn="ctr" indent="0" marL="0">
+              <a:buNone/>
+            </a:pPr>
+            <a:r>
+              <a:rPr lang="en-US" sz="1150" b="1" dirty="0">
+                <a:solidFill>
+                  <a:srgbClr val="FFFFFF"/>
                 </a:solidFill>
                 <a:latin typeface="Calibri" pitchFamily="34" charset="0"/>
                 <a:ea typeface="Calibri" pitchFamily="34" charset="-122"/>

</xml_diff>